<commit_message>
Deck: survey figures as percentages, staff count, wording changes on problem, platform and secure slides
Co-Authored-By: Claude Sonnet 5.5 <noreply@anthropic.com>
</commit_message>
<xml_diff>
--- a/marketing/presentation/Smart-Assess-Ja-Manchester-Presentation-v2.pptx
+++ b/marketing/presentation/Smart-Assess-Ja-Manchester-Presentation-v2.pptx
@@ -157,7 +157,7 @@
               <c:strCache>
                 <c:ptCount val="1"/>
                 <c:pt idx="0">
-                  <c:v>Students</c:v>
+                  <c:v>Percent of students</c:v>
                 </c:pt>
               </c:strCache>
             </c:strRef>
@@ -170,7 +170,7 @@
           </c:spPr>
           <c:invertIfNegative val="0"/>
           <c:dLbls>
-            <c:numFmt formatCode="#,##0" sourceLinked="0"/>
+            <c:numFmt formatCode="0&quot;%&quot;" sourceLinked="0"/>
             <c:txPr>
               <a:bodyPr/>
               <a:lstStyle/>
@@ -228,29 +228,29 @@
                 <c:formatCode>General</c:formatCode>
                 <c:ptCount val="6"/>
                 <c:pt idx="0">
-                  <c:v>11</c:v>
+                  <c:v>92</c:v>
                 </c:pt>
                 <c:pt idx="1">
-                  <c:v>7</c:v>
+                  <c:v>58</c:v>
                 </c:pt>
                 <c:pt idx="2">
-                  <c:v>6</c:v>
+                  <c:v>50</c:v>
                 </c:pt>
                 <c:pt idx="3">
-                  <c:v>4</c:v>
+                  <c:v>33</c:v>
                 </c:pt>
                 <c:pt idx="4">
-                  <c:v>3</c:v>
+                  <c:v>25</c:v>
                 </c:pt>
                 <c:pt idx="5">
-                  <c:v>3</c:v>
+                  <c:v>25</c:v>
                 </c:pt>
               </c:numCache>
             </c:numRef>
           </c:val>
         </c:ser>
         <c:dLbls>
-          <c:numFmt formatCode="#,##0" sourceLinked="0"/>
+          <c:numFmt formatCode="0&quot;%&quot;" sourceLinked="0"/>
           <c:txPr>
             <a:bodyPr/>
             <a:lstStyle/>
@@ -324,7 +324,7 @@
         <c:axId val="2094734552"/>
         <c:scaling>
           <c:orientation val="minMax"/>
-          <c:max val="13"/>
+          <c:max val="105"/>
           <c:min val="0"/>
         </c:scaling>
         <c:delete val="1"/>
@@ -406,7 +406,7 @@
               <c:strCache>
                 <c:ptCount val="1"/>
                 <c:pt idx="0">
-                  <c:v>Students</c:v>
+                  <c:v>Percent of students</c:v>
                 </c:pt>
               </c:strCache>
             </c:strRef>
@@ -419,7 +419,7 @@
           </c:spPr>
           <c:invertIfNegative val="0"/>
           <c:dLbls>
-            <c:numFmt formatCode="#,##0" sourceLinked="0"/>
+            <c:numFmt formatCode="0&quot;%&quot;" sourceLinked="0"/>
             <c:txPr>
               <a:bodyPr/>
               <a:lstStyle/>
@@ -474,26 +474,26 @@
                 <c:formatCode>General</c:formatCode>
                 <c:ptCount val="5"/>
                 <c:pt idx="0">
-                  <c:v>9</c:v>
+                  <c:v>75</c:v>
                 </c:pt>
                 <c:pt idx="1">
-                  <c:v>7</c:v>
+                  <c:v>58</c:v>
                 </c:pt>
                 <c:pt idx="2">
-                  <c:v>6</c:v>
+                  <c:v>50</c:v>
                 </c:pt>
                 <c:pt idx="3">
-                  <c:v>5</c:v>
+                  <c:v>42</c:v>
                 </c:pt>
                 <c:pt idx="4">
-                  <c:v>5</c:v>
+                  <c:v>42</c:v>
                 </c:pt>
               </c:numCache>
             </c:numRef>
           </c:val>
         </c:ser>
         <c:dLbls>
-          <c:numFmt formatCode="#,##0" sourceLinked="0"/>
+          <c:numFmt formatCode="0&quot;%&quot;" sourceLinked="0"/>
           <c:txPr>
             <a:bodyPr/>
             <a:lstStyle/>
@@ -567,7 +567,7 @@
         <c:axId val="2094734552"/>
         <c:scaling>
           <c:orientation val="minMax"/>
-          <c:max val="13"/>
+          <c:max val="105"/>
           <c:min val="0"/>
         </c:scaling>
         <c:delete val="1"/>
@@ -649,7 +649,7 @@
               <c:strCache>
                 <c:ptCount val="1"/>
                 <c:pt idx="0">
-                  <c:v>Teachers</c:v>
+                  <c:v>Percent of teachers</c:v>
                 </c:pt>
               </c:strCache>
             </c:strRef>
@@ -662,7 +662,7 @@
           </c:spPr>
           <c:invertIfNegative val="0"/>
           <c:dLbls>
-            <c:numFmt formatCode="#,##0" sourceLinked="0"/>
+            <c:numFmt formatCode="0&quot;%&quot;" sourceLinked="0"/>
             <c:txPr>
               <a:bodyPr/>
               <a:lstStyle/>
@@ -717,26 +717,26 @@
                 <c:formatCode>General</c:formatCode>
                 <c:ptCount val="5"/>
                 <c:pt idx="0">
-                  <c:v>8</c:v>
+                  <c:v>80</c:v>
                 </c:pt>
                 <c:pt idx="1">
-                  <c:v>6</c:v>
+                  <c:v>60</c:v>
                 </c:pt>
                 <c:pt idx="2">
-                  <c:v>5</c:v>
+                  <c:v>50</c:v>
                 </c:pt>
                 <c:pt idx="3">
-                  <c:v>4</c:v>
+                  <c:v>40</c:v>
                 </c:pt>
                 <c:pt idx="4">
-                  <c:v>3</c:v>
+                  <c:v>30</c:v>
                 </c:pt>
               </c:numCache>
             </c:numRef>
           </c:val>
         </c:ser>
         <c:dLbls>
-          <c:numFmt formatCode="#,##0" sourceLinked="0"/>
+          <c:numFmt formatCode="0&quot;%&quot;" sourceLinked="0"/>
           <c:txPr>
             <a:bodyPr/>
             <a:lstStyle/>
@@ -810,7 +810,7 @@
         <c:axId val="2094734552"/>
         <c:scaling>
           <c:orientation val="minMax"/>
-          <c:max val="10"/>
+          <c:max val="105"/>
           <c:min val="0"/>
         </c:scaling>
         <c:delete val="1"/>
@@ -1445,7 +1445,7 @@
             <a:r>
               <a:rPr lang="en-US" dirty="0"/>
               <a:t>About 1.5 minutes.
-Teachers asked who is struggling and what the common mistakes are (8 and 7 of 10). Exam insight shows, per test, which questions the class missed, the wrong answer most students chose, which students may need support and why, and the class against its last five tests. Students get My Topics: their own results by topic, with a practise button. Leaders get department and school analytics.</a:t>
+Teachers asked who is struggling and what the common mistakes are (80% and 70%). Exam insight shows, per test, which questions the class missed, the wrong answer most students chose, which students may need support and why, and the class against its last five tests. Students get My Topics: their own results by topic, with a practise button. Leaders get department and school analytics.</a:t>
             </a:r>
             <a:endParaRPr lang="en-US" dirty="0"/>
           </a:p>
@@ -1712,7 +1712,7 @@
             <a:r>
               <a:rPr lang="en-US" dirty="0"/>
               <a:t>About 1.5 minutes.
-Smart Learning is for learning only: lessons, study support, catch-up and reading. Assessment tells you what happened; Learning helps you act on it. Lessons follow the national curriculum 5E model. Short check questions come at three levels, support, core and stretch, which answers the 9 of 10 who asked for different activities for different ability levels. The AI drafts a lesson plan from a subject, grade and topic; the teacher reviews it.</a:t>
+Smart Learning is for learning only: lessons, study support, catch-up and reading. Assessment tells you what happened; Learning helps you act on it. Lessons follow the national curriculum 5E model. Short check questions come at three levels, support, core and stretch, which answers the 90% who asked for different activities for different ability levels. The AI drafts a lesson plan from a subject, grade and topic; the teacher reviews it.</a:t>
             </a:r>
             <a:endParaRPr lang="en-US" dirty="0"/>
           </a:p>
@@ -1801,7 +1801,7 @@
             <a:r>
               <a:rPr lang="en-US" dirty="0"/>
               <a:t>About 1.5 minutes.
-The scenario: a student misses three days. The teacher records when each lesson was taught. The absent student is offered the lesson as a catch-up, works through it at their own pace, and the teacher sees who has caught up. 9 of 10 teachers asked for exactly this. The screen on the left is a real lesson from the Manchester demo school.</a:t>
+The scenario: a student misses three days. The teacher records when each lesson was taught. The absent student is offered the lesson as a catch-up, works through it at their own pace, and the teacher sees who has caught up. 90% of teachers asked for exactly this. The screen on the left is a real lesson from the Manchester demo school.</a:t>
             </a:r>
             <a:endParaRPr lang="en-US" dirty="0"/>
           </a:p>
@@ -1890,7 +1890,7 @@
             <a:r>
               <a:rPr lang="en-US" dirty="0"/>
               <a:t>About 1.5 minutes.
-What students and teachers told us they want, and what is built: flashcards (7 of 12 students chose them) with review spacing, so cards you miss come back sooner; support, core and stretch practice per lesson; a "Current and future" page for students and teachers (what is happening now and what is coming, including upcoming assignment reminders, with no email); and the teacher resource space. The screen on the right is a real lesson builder from the demo school, with the optional AI drafting button.</a:t>
+What students and teachers told us they want, and what is built: flashcards (58% of students chose them) with review spacing, so cards you miss come back sooner; support, core and stretch practice per lesson; a "Current and future" page for students and teachers (what is happening now and what is coming, including upcoming assignment reminders, with no email); and the teacher resource space. The screen on the right is a real lesson builder from the demo school, with the optional AI drafting button.</a:t>
             </a:r>
             <a:endParaRPr lang="en-US" dirty="0"/>
           </a:p>
@@ -3405,7 +3405,7 @@
             <a:r>
               <a:rPr lang="en-US" dirty="0"/>
               <a:t>About 1 minute.
-Manchester High School is about 1,800 students. Every test, lesson and class produces information. The question is whether teachers and leaders can see it, in time to act.</a:t>
+Manchester High School is about 1,800 students and more than 100 members of staff. Every test, lesson and class produces information. The question is whether teachers and leaders can see it, in time to act.</a:t>
             </a:r>
             <a:endParaRPr lang="en-US" dirty="0"/>
           </a:p>
@@ -3583,7 +3583,7 @@
             <a:r>
               <a:rPr lang="en-US" dirty="0"/>
               <a:t>About 1.5 minutes.
-Ten teachers. Marking is the biggest time cost (8 of 10). Nine of ten want the system to show what an absent student missed, and nine of ten want activities for different ability levels. Eight of ten want AI-assisted lesson planning. Everything on this slide is something we have now built; the last two slides before the demo show how.</a:t>
+Ten teachers. Marking is the biggest time cost (80% of teachers). 90% want the system to show what an absent student missed, and 90% want activities for different ability levels. 80% want AI-assisted lesson planning. Everything on this slide is something we have now built; the last two slides before the demo show how.</a:t>
             </a:r>
             <a:endParaRPr lang="en-US" dirty="0"/>
           </a:p>
@@ -3672,7 +3672,7 @@
             <a:r>
               <a:rPr lang="en-US" dirty="0"/>
               <a:t>About 1 minute.
-One school, three products with three different jobs. Assess measures learning. Learning delivers and recovers it. Play makes practice engaging. Two are already built and in use at Manchester; Play is built and held back until you choose to launch it.</a:t>
+One platform, three products with three different jobs. Assess measures learning. Learning delivers and recovers it. Play makes practice engaging. Two are already built and in use at Manchester; Play is built and held back until you choose to launch it.</a:t>
             </a:r>
             <a:endParaRPr lang="en-US" dirty="0"/>
           </a:p>
@@ -3760,7 +3760,7 @@
           <a:p>
             <a:r>
               <a:rPr lang="en-US" dirty="0"/>
-              <a:t>About half a minute. One line: Smart Assess is for assessment only. The next four slides show building, marking, results and security. 8 of 10 teachers named marking as their biggest time cost, so that is where we start.</a:t>
+              <a:t>About half a minute. One line: Smart Assess is for assessment only. The next four slides show building, marking, results and security. 80% of teachers named marking as their biggest time cost, so that is where we start.</a:t>
             </a:r>
             <a:endParaRPr lang="en-US" dirty="0"/>
           </a:p>
@@ -6261,7 +6261,7 @@
                 <a:ea typeface="Arial" pitchFamily="34" charset="-122"/>
                 <a:cs typeface="Arial" pitchFamily="34" charset="-120"/>
               </a:rPr>
-              <a:t>8 of 10 teachers named marking as the biggest drain on their time.</a:t>
+              <a:t>80% of teachers named marking as the biggest drain on their time.</a:t>
             </a:r>
             <a:endParaRPr lang="en-US" sz="1400" dirty="0"/>
           </a:p>
@@ -7537,7 +7537,7 @@
                 <a:ea typeface="Arial" pitchFamily="34" charset="-122"/>
                 <a:cs typeface="Arial" pitchFamily="34" charset="-120"/>
               </a:rPr>
-              <a:t>Teachers asked who is struggling (8 of 10) and what mistakes are common (7 of 10).</a:t>
+              <a:t>Teachers asked who is struggling (80%) and what mistakes are common (70%).</a:t>
             </a:r>
             <a:endParaRPr lang="en-US" sz="1400" dirty="0"/>
           </a:p>
@@ -7968,7 +7968,7 @@
               <a:buNone/>
             </a:pPr>
             <a:r>
-              <a:rPr lang="en-US" sz="4600" dirty="0">
+              <a:rPr lang="en-US" sz="3600" dirty="0">
                 <a:solidFill>
                   <a:srgbClr val="1E1208"/>
                 </a:solidFill>
@@ -7976,9 +7976,9 @@
                 <a:ea typeface="Impact" pitchFamily="34" charset="-122"/>
                 <a:cs typeface="Impact" pitchFamily="34" charset="-120"/>
               </a:rPr>
-              <a:t>FAIR, SECURE AND ACCESSIBLE BY DESIGN</a:t>
-            </a:r>
-            <a:endParaRPr lang="en-US" sz="4600" dirty="0"/>
+              <a:t>FAIR, SECURE AND SUPPORTIVE OF EACH STUDENT'S ACCESSIBILITY</a:t>
+            </a:r>
+            <a:endParaRPr lang="en-US" sz="3600" dirty="0"/>
           </a:p>
         </p:txBody>
       </p:sp>
@@ -13847,7 +13847,7 @@
                 <a:ea typeface="Arial" pitchFamily="34" charset="-122"/>
                 <a:cs typeface="Arial" pitchFamily="34" charset="-120"/>
               </a:rPr>
-              <a:t>7 of 12 students chose flashcards. 9 of 10 teachers asked for activities at different ability levels.</a:t>
+              <a:t>58% of students chose flashcards. 90% of teachers asked for activities at different ability levels.</a:t>
             </a:r>
             <a:endParaRPr lang="en-US" sz="1300" dirty="0"/>
           </a:p>
@@ -28674,7 +28674,7 @@
                           <a:ea typeface="Arial" pitchFamily="34" charset="-122"/>
                           <a:cs typeface="Arial" pitchFamily="34" charset="-120"/>
                         </a:rPr>
-                        <a:t>Marking takes the most time (8 of 10 teachers)</a:t>
+                        <a:t>Marking takes the most time (80% of teachers)</a:t>
                       </a:r>
                       <a:endParaRPr lang="en-US" sz="1200" dirty="0">
                         <a:latin typeface="Arial" charset="0"/>
@@ -28880,7 +28880,7 @@
                           <a:ea typeface="Arial" pitchFamily="34" charset="-122"/>
                           <a:cs typeface="Arial" pitchFamily="34" charset="-120"/>
                         </a:rPr>
-                        <a:t>Who is struggling, what mistakes are common (8 and 7 of 10)</a:t>
+                        <a:t>Who is struggling, what mistakes are common (80% and 70% of teachers)</a:t>
                       </a:r>
                       <a:endParaRPr lang="en-US" sz="1200" dirty="0">
                         <a:latin typeface="Arial" charset="0"/>
@@ -29086,7 +29086,7 @@
                           <a:ea typeface="Arial" pitchFamily="34" charset="-122"/>
                           <a:cs typeface="Arial" pitchFamily="34" charset="-120"/>
                         </a:rPr>
-                        <a:t>What a missed student missed (9 of 10)</a:t>
+                        <a:t>What a missed student missed (90% of teachers)</a:t>
                       </a:r>
                       <a:endParaRPr lang="en-US" sz="1200" dirty="0">
                         <a:latin typeface="Arial" charset="0"/>
@@ -29292,7 +29292,7 @@
                           <a:ea typeface="Arial" pitchFamily="34" charset="-122"/>
                           <a:cs typeface="Arial" pitchFamily="34" charset="-120"/>
                         </a:rPr>
-                        <a:t>Activities for different ability levels (9 of 10)</a:t>
+                        <a:t>Activities for different ability levels (90% of teachers)</a:t>
                       </a:r>
                       <a:endParaRPr lang="en-US" sz="1200" dirty="0">
                         <a:latin typeface="Arial" charset="0"/>
@@ -29498,7 +29498,7 @@
                           <a:ea typeface="Arial" pitchFamily="34" charset="-122"/>
                           <a:cs typeface="Arial" pitchFamily="34" charset="-120"/>
                         </a:rPr>
-                        <a:t>AI-assisted lesson planning (8 of 10)</a:t>
+                        <a:t>AI-assisted lesson planning (80% of teachers)</a:t>
                       </a:r>
                       <a:endParaRPr lang="en-US" sz="1200" dirty="0">
                         <a:latin typeface="Arial" charset="0"/>
@@ -29704,7 +29704,7 @@
                           <a:ea typeface="Arial" pitchFamily="34" charset="-122"/>
                           <a:cs typeface="Arial" pitchFamily="34" charset="-120"/>
                         </a:rPr>
-                        <a:t>Topics I need to improve (9 of 12 students)</a:t>
+                        <a:t>Topics I need to improve (75% of students)</a:t>
                       </a:r>
                       <a:endParaRPr lang="en-US" sz="1200" dirty="0">
                         <a:latin typeface="Arial" charset="0"/>
@@ -29910,7 +29910,7 @@
                           <a:ea typeface="Arial" pitchFamily="34" charset="-122"/>
                           <a:cs typeface="Arial" pitchFamily="34" charset="-120"/>
                         </a:rPr>
-                        <a:t>Flashcards (7 of 12 students)</a:t>
+                        <a:t>Flashcards (58% of students)</a:t>
                       </a:r>
                       <a:endParaRPr lang="en-US" sz="1200" dirty="0">
                         <a:latin typeface="Arial" charset="0"/>
@@ -30116,7 +30116,7 @@
                           <a:ea typeface="Arial" pitchFamily="34" charset="-122"/>
                           <a:cs typeface="Arial" pitchFamily="34" charset="-120"/>
                         </a:rPr>
-                        <a:t>Step-by-step explanations (11 of 12 students)</a:t>
+                        <a:t>Step-by-step explanations (92% of students)</a:t>
                       </a:r>
                       <a:endParaRPr lang="en-US" sz="1200" dirty="0">
                         <a:latin typeface="Arial" charset="0"/>
@@ -34155,7 +34155,7 @@
                 <a:ea typeface="Arial" pitchFamily="34" charset="-122"/>
                 <a:cs typeface="Arial" pitchFamily="34" charset="-120"/>
               </a:rPr>
-              <a:t>Time. Cost. Paper. Administration. Repetition.</a:t>
+              <a:t>This consumes time, money, paper and administrative effort.</a:t>
             </a:r>
             <a:endParaRPr lang="en-US" sz="1500" dirty="0"/>
           </a:p>
@@ -35237,7 +35237,7 @@
               <a:buNone/>
             </a:pPr>
             <a:r>
-              <a:rPr lang="en-US" sz="4600" dirty="0">
+              <a:rPr lang="en-US" sz="4300" dirty="0">
                 <a:solidFill>
                   <a:srgbClr val="1E1208"/>
                 </a:solidFill>
@@ -35245,9 +35245,9 @@
                 <a:ea typeface="Impact" pitchFamily="34" charset="-122"/>
                 <a:cs typeface="Impact" pitchFamily="34" charset="-120"/>
               </a:rPr>
-              <a:t>ONE SCHOOL OF ABOUT 1,800 STUDENTS</a:t>
-            </a:r>
-            <a:endParaRPr lang="en-US" sz="4600" dirty="0"/>
+              <a:t>ONE SCHOOL OF ABOUT 1,800 STUDENTS AND 100+ STAFF</a:t>
+            </a:r>
+            <a:endParaRPr lang="en-US" sz="4300" dirty="0"/>
           </a:p>
         </p:txBody>
       </p:sp>
@@ -35284,8 +35284,8 @@
         </p:nvSpPr>
         <p:spPr>
           <a:xfrm>
-            <a:off x="1645920" y="2194560"/>
-            <a:ext cx="3474720" cy="1645920"/>
+            <a:off x="1645920" y="2057400"/>
+            <a:ext cx="3474720" cy="1005840"/>
           </a:xfrm>
           <a:prstGeom prst="rect">
             <a:avLst/>
@@ -35304,7 +35304,7 @@
               <a:buNone/>
             </a:pPr>
             <a:r>
-              <a:rPr lang="en-US" sz="8800" dirty="0">
+              <a:rPr lang="en-US" sz="6600" dirty="0">
                 <a:solidFill>
                   <a:srgbClr val="1E1208"/>
                 </a:solidFill>
@@ -35314,7 +35314,7 @@
               </a:rPr>
               <a:t>≈1,800</a:t>
             </a:r>
-            <a:endParaRPr lang="en-US" sz="8800" dirty="0"/>
+            <a:endParaRPr lang="en-US" sz="6600" dirty="0"/>
           </a:p>
         </p:txBody>
       </p:sp>
@@ -35326,8 +35326,8 @@
         </p:nvSpPr>
         <p:spPr>
           <a:xfrm>
-            <a:off x="1645920" y="3840480"/>
-            <a:ext cx="3383280" cy="640080"/>
+            <a:off x="1645920" y="3017520"/>
+            <a:ext cx="3383280" cy="411480"/>
           </a:xfrm>
           <a:prstGeom prst="rect">
             <a:avLst/>
@@ -35346,7 +35346,7 @@
               <a:buNone/>
             </a:pPr>
             <a:r>
-              <a:rPr lang="en-US" sz="3000" dirty="0">
+              <a:rPr lang="en-US" sz="2400" dirty="0">
                 <a:solidFill>
                   <a:srgbClr val="1E1208"/>
                 </a:solidFill>
@@ -35356,7 +35356,7 @@
               </a:rPr>
               <a:t>STUDENTS</a:t>
             </a:r>
-            <a:endParaRPr lang="en-US" sz="3000" dirty="0"/>
+            <a:endParaRPr lang="en-US" sz="2400" dirty="0"/>
           </a:p>
         </p:txBody>
       </p:sp>
@@ -35368,8 +35368,8 @@
         </p:nvSpPr>
         <p:spPr>
           <a:xfrm>
-            <a:off x="1645920" y="4526280"/>
-            <a:ext cx="3383280" cy="1005840"/>
+            <a:off x="1645920" y="3474720"/>
+            <a:ext cx="3474720" cy="914400"/>
           </a:xfrm>
           <a:prstGeom prst="rect">
             <a:avLst/>
@@ -35388,7 +35388,91 @@
               <a:buNone/>
             </a:pPr>
             <a:r>
-              <a:rPr lang="en-US" sz="1400" b="1" dirty="0">
+              <a:rPr lang="en-US" sz="6600" dirty="0">
+                <a:solidFill>
+                  <a:srgbClr val="1E1208"/>
+                </a:solidFill>
+                <a:latin typeface="Impact" pitchFamily="34" charset="0"/>
+                <a:ea typeface="Impact" pitchFamily="34" charset="-122"/>
+                <a:cs typeface="Impact" pitchFamily="34" charset="-120"/>
+              </a:rPr>
+              <a:t>100+</a:t>
+            </a:r>
+            <a:endParaRPr lang="en-US" sz="6600" dirty="0"/>
+          </a:p>
+        </p:txBody>
+      </p:sp>
+      <p:sp>
+        <p:nvSpPr>
+          <p:cNvPr id="19" name="Text 16"/>
+          <p:cNvSpPr/>
+          <p:nvPr/>
+        </p:nvSpPr>
+        <p:spPr>
+          <a:xfrm>
+            <a:off x="1645920" y="4389120"/>
+            <a:ext cx="3383280" cy="411480"/>
+          </a:xfrm>
+          <a:prstGeom prst="rect">
+            <a:avLst/>
+          </a:prstGeom>
+          <a:noFill/>
+          <a:ln/>
+        </p:spPr>
+        <p:txBody>
+          <a:bodyPr wrap="square" lIns="0" tIns="0" rIns="0" bIns="0" rtlCol="0" anchor="t"/>
+          <a:lstStyle/>
+          <a:p>
+            <a:pPr algn="l" indent="0" marL="0">
+              <a:lnSpc>
+                <a:spcPct val="110000"/>
+              </a:lnSpc>
+              <a:buNone/>
+            </a:pPr>
+            <a:r>
+              <a:rPr lang="en-US" sz="2400" dirty="0">
+                <a:solidFill>
+                  <a:srgbClr val="1E1208"/>
+                </a:solidFill>
+                <a:latin typeface="Impact" pitchFamily="34" charset="0"/>
+                <a:ea typeface="Impact" pitchFamily="34" charset="-122"/>
+                <a:cs typeface="Impact" pitchFamily="34" charset="-120"/>
+              </a:rPr>
+              <a:t>MEMBERS OF STAFF</a:t>
+            </a:r>
+            <a:endParaRPr lang="en-US" sz="2400" dirty="0"/>
+          </a:p>
+        </p:txBody>
+      </p:sp>
+      <p:sp>
+        <p:nvSpPr>
+          <p:cNvPr id="20" name="Text 17"/>
+          <p:cNvSpPr/>
+          <p:nvPr/>
+        </p:nvSpPr>
+        <p:spPr>
+          <a:xfrm>
+            <a:off x="1645920" y="4937760"/>
+            <a:ext cx="3383280" cy="731520"/>
+          </a:xfrm>
+          <a:prstGeom prst="rect">
+            <a:avLst/>
+          </a:prstGeom>
+          <a:noFill/>
+          <a:ln/>
+        </p:spPr>
+        <p:txBody>
+          <a:bodyPr wrap="square" lIns="0" tIns="0" rIns="0" bIns="0" rtlCol="0" anchor="t"/>
+          <a:lstStyle/>
+          <a:p>
+            <a:pPr algn="l" indent="0" marL="0">
+              <a:lnSpc>
+                <a:spcPct val="110000"/>
+              </a:lnSpc>
+              <a:buNone/>
+            </a:pPr>
+            <a:r>
+              <a:rPr lang="en-US" sz="1300" b="1" dirty="0">
                 <a:solidFill>
                   <a:srgbClr val="1E1208"/>
                 </a:solidFill>
@@ -35396,15 +35480,15 @@
                 <a:ea typeface="Arial" pitchFamily="34" charset="-122"/>
                 <a:cs typeface="Arial" pitchFamily="34" charset="-120"/>
               </a:rPr>
-              <a:t>Every test, lesson and class creates information. The question is whether teachers and leaders can see it.</a:t>
-            </a:r>
-            <a:endParaRPr lang="en-US" sz="1400" dirty="0"/>
-          </a:p>
-        </p:txBody>
-      </p:sp>
-      <p:sp>
-        <p:nvSpPr>
-          <p:cNvPr id="19" name="Shape 16"/>
+              <a:t>Every test, lesson and class creates information. Can teachers and leaders see it?</a:t>
+            </a:r>
+            <a:endParaRPr lang="en-US" sz="1300" dirty="0"/>
+          </a:p>
+        </p:txBody>
+      </p:sp>
+      <p:sp>
+        <p:nvSpPr>
+          <p:cNvPr id="21" name="Shape 18"/>
           <p:cNvSpPr/>
           <p:nvPr/>
         </p:nvSpPr>
@@ -35429,7 +35513,7 @@
       </p:sp>
       <p:sp>
         <p:nvSpPr>
-          <p:cNvPr id="20" name="Text 17"/>
+          <p:cNvPr id="22" name="Text 19"/>
           <p:cNvSpPr/>
           <p:nvPr/>
         </p:nvSpPr>
@@ -35471,7 +35555,7 @@
       </p:sp>
       <p:sp>
         <p:nvSpPr>
-          <p:cNvPr id="21" name="Text 18"/>
+          <p:cNvPr id="23" name="Text 20"/>
           <p:cNvSpPr/>
           <p:nvPr/>
         </p:nvSpPr>
@@ -35513,7 +35597,7 @@
       </p:sp>
       <p:sp>
         <p:nvSpPr>
-          <p:cNvPr id="22" name="Shape 19"/>
+          <p:cNvPr id="24" name="Shape 21"/>
           <p:cNvSpPr/>
           <p:nvPr/>
         </p:nvSpPr>
@@ -35538,7 +35622,7 @@
       </p:sp>
       <p:sp>
         <p:nvSpPr>
-          <p:cNvPr id="23" name="Text 20"/>
+          <p:cNvPr id="25" name="Text 22"/>
           <p:cNvSpPr/>
           <p:nvPr/>
         </p:nvSpPr>
@@ -35580,7 +35664,7 @@
       </p:sp>
       <p:sp>
         <p:nvSpPr>
-          <p:cNvPr id="24" name="Text 21"/>
+          <p:cNvPr id="26" name="Text 23"/>
           <p:cNvSpPr/>
           <p:nvPr/>
         </p:nvSpPr>
@@ -35622,7 +35706,7 @@
       </p:sp>
       <p:sp>
         <p:nvSpPr>
-          <p:cNvPr id="25" name="Shape 22"/>
+          <p:cNvPr id="27" name="Shape 24"/>
           <p:cNvSpPr/>
           <p:nvPr/>
         </p:nvSpPr>
@@ -35647,7 +35731,7 @@
       </p:sp>
       <p:sp>
         <p:nvSpPr>
-          <p:cNvPr id="26" name="Text 23"/>
+          <p:cNvPr id="28" name="Text 25"/>
           <p:cNvSpPr/>
           <p:nvPr/>
         </p:nvSpPr>
@@ -35689,7 +35773,7 @@
       </p:sp>
       <p:sp>
         <p:nvSpPr>
-          <p:cNvPr id="27" name="Text 24"/>
+          <p:cNvPr id="29" name="Text 26"/>
           <p:cNvSpPr/>
           <p:nvPr/>
         </p:nvSpPr>
@@ -35731,7 +35815,7 @@
       </p:sp>
       <p:sp>
         <p:nvSpPr>
-          <p:cNvPr id="28" name="Shape 25"/>
+          <p:cNvPr id="30" name="Shape 27"/>
           <p:cNvSpPr/>
           <p:nvPr/>
         </p:nvSpPr>
@@ -35756,7 +35840,7 @@
       </p:sp>
       <p:sp>
         <p:nvSpPr>
-          <p:cNvPr id="29" name="Text 26"/>
+          <p:cNvPr id="31" name="Text 28"/>
           <p:cNvSpPr/>
           <p:nvPr/>
         </p:nvSpPr>
@@ -35798,7 +35882,7 @@
       </p:sp>
       <p:sp>
         <p:nvSpPr>
-          <p:cNvPr id="30" name="Text 27"/>
+          <p:cNvPr id="32" name="Text 29"/>
           <p:cNvSpPr/>
           <p:nvPr/>
         </p:nvSpPr>
@@ -36230,7 +36314,7 @@
                 <a:ea typeface="Courier New" pitchFamily="34" charset="-122"/>
                 <a:cs typeface="Courier New" pitchFamily="34" charset="-120"/>
               </a:rPr>
-              <a:t>WHAT 12 MANCHESTER STUDENTS TOLD US</a:t>
+              <a:t>WHAT MANCHESTER STUDENTS TOLD US</a:t>
             </a:r>
             <a:endParaRPr lang="en-US" sz="1150" dirty="0"/>
           </a:p>
@@ -36449,7 +36533,7 @@
                 <a:ea typeface="Arial" pitchFamily="34" charset="-122"/>
                 <a:cs typeface="Arial" pitchFamily="34" charset="-120"/>
               </a:rPr>
-              <a:t>10 of 12 want help studying for exams. 7 of 12 chose flashcards for practice.</a:t>
+              <a:t>83% want help studying for exams. 58% chose flashcards for practice.</a:t>
             </a:r>
             <a:endParaRPr lang="en-US" sz="1500" dirty="0"/>
           </a:p>
@@ -36889,7 +36973,7 @@
                 <a:ea typeface="Courier New" pitchFamily="34" charset="-122"/>
                 <a:cs typeface="Courier New" pitchFamily="34" charset="-120"/>
               </a:rPr>
-              <a:t>WHAT 10 MANCHESTER TEACHERS TOLD US</a:t>
+              <a:t>WHAT MANCHESTER TEACHERS TOLD US</a:t>
             </a:r>
             <a:endParaRPr lang="en-US" sz="1150" dirty="0"/>
           </a:p>
@@ -37028,7 +37112,7 @@
         <p:spPr>
           <a:xfrm>
             <a:off x="7452360" y="1965960"/>
-            <a:ext cx="640080" cy="960120"/>
+            <a:ext cx="1325880" cy="960120"/>
           </a:xfrm>
           <a:prstGeom prst="rect">
             <a:avLst/>
@@ -37047,7 +37131,7 @@
               <a:buNone/>
             </a:pPr>
             <a:r>
-              <a:rPr lang="en-US" sz="4600" dirty="0">
+              <a:rPr lang="en-US" sz="4000" dirty="0">
                 <a:solidFill>
                   <a:srgbClr val="1E1208"/>
                 </a:solidFill>
@@ -37055,9 +37139,9 @@
                 <a:ea typeface="Impact" pitchFamily="34" charset="-122"/>
                 <a:cs typeface="Impact" pitchFamily="34" charset="-120"/>
               </a:rPr>
-              <a:t>9</a:t>
-            </a:r>
-            <a:endParaRPr lang="en-US" sz="4600" dirty="0"/>
+              <a:t>90%</a:t>
+            </a:r>
+            <a:endParaRPr lang="en-US" sz="4000" dirty="0"/>
           </a:p>
         </p:txBody>
       </p:sp>
@@ -37069,17 +37153,17 @@
         </p:nvSpPr>
         <p:spPr>
           <a:xfrm>
-            <a:off x="8092440" y="2075688"/>
-            <a:ext cx="914400" cy="274320"/>
-          </a:xfrm>
-          <a:prstGeom prst="rect">
-            <a:avLst/>
-          </a:prstGeom>
-          <a:noFill/>
-          <a:ln/>
-        </p:spPr>
-        <p:txBody>
-          <a:bodyPr wrap="square" lIns="0" tIns="0" rIns="0" bIns="0" rtlCol="0" anchor="t"/>
+            <a:off x="8778240" y="1965960"/>
+            <a:ext cx="2057400" cy="960120"/>
+          </a:xfrm>
+          <a:prstGeom prst="rect">
+            <a:avLst/>
+          </a:prstGeom>
+          <a:noFill/>
+          <a:ln/>
+        </p:spPr>
+        <p:txBody>
+          <a:bodyPr wrap="square" lIns="0" tIns="0" rIns="0" bIns="0" rtlCol="0" anchor="ctr"/>
           <a:lstStyle/>
           <a:p>
             <a:pPr algn="l" indent="0" marL="0">
@@ -37089,49 +37173,7 @@
               <a:buNone/>
             </a:pPr>
             <a:r>
-              <a:rPr lang="en-US" sz="1400" dirty="0">
-                <a:solidFill>
-                  <a:srgbClr val="1E1208"/>
-                </a:solidFill>
-                <a:latin typeface="Impact" pitchFamily="34" charset="0"/>
-                <a:ea typeface="Impact" pitchFamily="34" charset="-122"/>
-                <a:cs typeface="Impact" pitchFamily="34" charset="-120"/>
-              </a:rPr>
-              <a:t>OF 10</a:t>
-            </a:r>
-            <a:endParaRPr lang="en-US" sz="1400" dirty="0"/>
-          </a:p>
-        </p:txBody>
-      </p:sp>
-      <p:sp>
-        <p:nvSpPr>
-          <p:cNvPr id="20" name="Text 16"/>
-          <p:cNvSpPr/>
-          <p:nvPr/>
-        </p:nvSpPr>
-        <p:spPr>
-          <a:xfrm>
-            <a:off x="8092440" y="2313432"/>
-            <a:ext cx="2743200" cy="594360"/>
-          </a:xfrm>
-          <a:prstGeom prst="rect">
-            <a:avLst/>
-          </a:prstGeom>
-          <a:noFill/>
-          <a:ln/>
-        </p:spPr>
-        <p:txBody>
-          <a:bodyPr wrap="square" lIns="0" tIns="0" rIns="0" bIns="0" rtlCol="0" anchor="t"/>
-          <a:lstStyle/>
-          <a:p>
-            <a:pPr algn="l" indent="0" marL="0">
-              <a:lnSpc>
-                <a:spcPct val="110000"/>
-              </a:lnSpc>
-              <a:buNone/>
-            </a:pPr>
-            <a:r>
-              <a:rPr lang="en-US" sz="1150" b="1" dirty="0">
+              <a:rPr lang="en-US" sz="1100" b="1" dirty="0">
                 <a:solidFill>
                   <a:srgbClr val="1E1208"/>
                 </a:solidFill>
@@ -37141,13 +37183,13 @@
               </a:rPr>
               <a:t>want the system to show what an absent student missed</a:t>
             </a:r>
-            <a:endParaRPr lang="en-US" sz="1150" dirty="0"/>
-          </a:p>
-        </p:txBody>
-      </p:sp>
-      <p:sp>
-        <p:nvSpPr>
-          <p:cNvPr id="21" name="Shape 17"/>
+            <a:endParaRPr lang="en-US" sz="1100" dirty="0"/>
+          </a:p>
+        </p:txBody>
+      </p:sp>
+      <p:sp>
+        <p:nvSpPr>
+          <p:cNvPr id="20" name="Shape 16"/>
           <p:cNvSpPr/>
           <p:nvPr/>
         </p:nvSpPr>
@@ -37172,14 +37214,14 @@
       </p:sp>
       <p:sp>
         <p:nvSpPr>
-          <p:cNvPr id="22" name="Text 18"/>
+          <p:cNvPr id="21" name="Text 17"/>
           <p:cNvSpPr/>
           <p:nvPr/>
         </p:nvSpPr>
         <p:spPr>
           <a:xfrm>
             <a:off x="7452360" y="3063240"/>
-            <a:ext cx="640080" cy="960120"/>
+            <a:ext cx="1325880" cy="960120"/>
           </a:xfrm>
           <a:prstGeom prst="rect">
             <a:avLst/>
@@ -37198,7 +37240,7 @@
               <a:buNone/>
             </a:pPr>
             <a:r>
-              <a:rPr lang="en-US" sz="4600" dirty="0">
+              <a:rPr lang="en-US" sz="4000" dirty="0">
                 <a:solidFill>
                   <a:srgbClr val="1E1208"/>
                 </a:solidFill>
@@ -37206,31 +37248,31 @@
                 <a:ea typeface="Impact" pitchFamily="34" charset="-122"/>
                 <a:cs typeface="Impact" pitchFamily="34" charset="-120"/>
               </a:rPr>
-              <a:t>9</a:t>
-            </a:r>
-            <a:endParaRPr lang="en-US" sz="4600" dirty="0"/>
-          </a:p>
-        </p:txBody>
-      </p:sp>
-      <p:sp>
-        <p:nvSpPr>
-          <p:cNvPr id="23" name="Text 19"/>
-          <p:cNvSpPr/>
-          <p:nvPr/>
-        </p:nvSpPr>
-        <p:spPr>
-          <a:xfrm>
-            <a:off x="8092440" y="3172968"/>
-            <a:ext cx="914400" cy="274320"/>
-          </a:xfrm>
-          <a:prstGeom prst="rect">
-            <a:avLst/>
-          </a:prstGeom>
-          <a:noFill/>
-          <a:ln/>
-        </p:spPr>
-        <p:txBody>
-          <a:bodyPr wrap="square" lIns="0" tIns="0" rIns="0" bIns="0" rtlCol="0" anchor="t"/>
+              <a:t>90%</a:t>
+            </a:r>
+            <a:endParaRPr lang="en-US" sz="4000" dirty="0"/>
+          </a:p>
+        </p:txBody>
+      </p:sp>
+      <p:sp>
+        <p:nvSpPr>
+          <p:cNvPr id="22" name="Text 18"/>
+          <p:cNvSpPr/>
+          <p:nvPr/>
+        </p:nvSpPr>
+        <p:spPr>
+          <a:xfrm>
+            <a:off x="8778240" y="3063240"/>
+            <a:ext cx="2057400" cy="960120"/>
+          </a:xfrm>
+          <a:prstGeom prst="rect">
+            <a:avLst/>
+          </a:prstGeom>
+          <a:noFill/>
+          <a:ln/>
+        </p:spPr>
+        <p:txBody>
+          <a:bodyPr wrap="square" lIns="0" tIns="0" rIns="0" bIns="0" rtlCol="0" anchor="ctr"/>
           <a:lstStyle/>
           <a:p>
             <a:pPr algn="l" indent="0" marL="0">
@@ -37240,49 +37282,7 @@
               <a:buNone/>
             </a:pPr>
             <a:r>
-              <a:rPr lang="en-US" sz="1400" dirty="0">
-                <a:solidFill>
-                  <a:srgbClr val="1E1208"/>
-                </a:solidFill>
-                <a:latin typeface="Impact" pitchFamily="34" charset="0"/>
-                <a:ea typeface="Impact" pitchFamily="34" charset="-122"/>
-                <a:cs typeface="Impact" pitchFamily="34" charset="-120"/>
-              </a:rPr>
-              <a:t>OF 10</a:t>
-            </a:r>
-            <a:endParaRPr lang="en-US" sz="1400" dirty="0"/>
-          </a:p>
-        </p:txBody>
-      </p:sp>
-      <p:sp>
-        <p:nvSpPr>
-          <p:cNvPr id="24" name="Text 20"/>
-          <p:cNvSpPr/>
-          <p:nvPr/>
-        </p:nvSpPr>
-        <p:spPr>
-          <a:xfrm>
-            <a:off x="8092440" y="3410712"/>
-            <a:ext cx="2743200" cy="594360"/>
-          </a:xfrm>
-          <a:prstGeom prst="rect">
-            <a:avLst/>
-          </a:prstGeom>
-          <a:noFill/>
-          <a:ln/>
-        </p:spPr>
-        <p:txBody>
-          <a:bodyPr wrap="square" lIns="0" tIns="0" rIns="0" bIns="0" rtlCol="0" anchor="t"/>
-          <a:lstStyle/>
-          <a:p>
-            <a:pPr algn="l" indent="0" marL="0">
-              <a:lnSpc>
-                <a:spcPct val="110000"/>
-              </a:lnSpc>
-              <a:buNone/>
-            </a:pPr>
-            <a:r>
-              <a:rPr lang="en-US" sz="1150" b="1" dirty="0">
+              <a:rPr lang="en-US" sz="1100" b="1" dirty="0">
                 <a:solidFill>
                   <a:srgbClr val="1E1208"/>
                 </a:solidFill>
@@ -37292,13 +37292,13 @@
               </a:rPr>
               <a:t>want different activities for different ability levels</a:t>
             </a:r>
-            <a:endParaRPr lang="en-US" sz="1150" dirty="0"/>
-          </a:p>
-        </p:txBody>
-      </p:sp>
-      <p:sp>
-        <p:nvSpPr>
-          <p:cNvPr id="25" name="Shape 21"/>
+            <a:endParaRPr lang="en-US" sz="1100" dirty="0"/>
+          </a:p>
+        </p:txBody>
+      </p:sp>
+      <p:sp>
+        <p:nvSpPr>
+          <p:cNvPr id="23" name="Shape 19"/>
           <p:cNvSpPr/>
           <p:nvPr/>
         </p:nvSpPr>
@@ -37323,14 +37323,14 @@
       </p:sp>
       <p:sp>
         <p:nvSpPr>
-          <p:cNvPr id="26" name="Text 22"/>
+          <p:cNvPr id="24" name="Text 20"/>
           <p:cNvSpPr/>
           <p:nvPr/>
         </p:nvSpPr>
         <p:spPr>
           <a:xfrm>
             <a:off x="7452360" y="4160520"/>
-            <a:ext cx="640080" cy="960120"/>
+            <a:ext cx="1325880" cy="960120"/>
           </a:xfrm>
           <a:prstGeom prst="rect">
             <a:avLst/>
@@ -37349,7 +37349,7 @@
               <a:buNone/>
             </a:pPr>
             <a:r>
-              <a:rPr lang="en-US" sz="4600" dirty="0">
+              <a:rPr lang="en-US" sz="4000" dirty="0">
                 <a:solidFill>
                   <a:srgbClr val="1E1208"/>
                 </a:solidFill>
@@ -37357,31 +37357,31 @@
                 <a:ea typeface="Impact" pitchFamily="34" charset="-122"/>
                 <a:cs typeface="Impact" pitchFamily="34" charset="-120"/>
               </a:rPr>
-              <a:t>8</a:t>
-            </a:r>
-            <a:endParaRPr lang="en-US" sz="4600" dirty="0"/>
-          </a:p>
-        </p:txBody>
-      </p:sp>
-      <p:sp>
-        <p:nvSpPr>
-          <p:cNvPr id="27" name="Text 23"/>
-          <p:cNvSpPr/>
-          <p:nvPr/>
-        </p:nvSpPr>
-        <p:spPr>
-          <a:xfrm>
-            <a:off x="8092440" y="4270248"/>
-            <a:ext cx="914400" cy="274320"/>
-          </a:xfrm>
-          <a:prstGeom prst="rect">
-            <a:avLst/>
-          </a:prstGeom>
-          <a:noFill/>
-          <a:ln/>
-        </p:spPr>
-        <p:txBody>
-          <a:bodyPr wrap="square" lIns="0" tIns="0" rIns="0" bIns="0" rtlCol="0" anchor="t"/>
+              <a:t>80%</a:t>
+            </a:r>
+            <a:endParaRPr lang="en-US" sz="4000" dirty="0"/>
+          </a:p>
+        </p:txBody>
+      </p:sp>
+      <p:sp>
+        <p:nvSpPr>
+          <p:cNvPr id="25" name="Text 21"/>
+          <p:cNvSpPr/>
+          <p:nvPr/>
+        </p:nvSpPr>
+        <p:spPr>
+          <a:xfrm>
+            <a:off x="8778240" y="4160520"/>
+            <a:ext cx="2057400" cy="960120"/>
+          </a:xfrm>
+          <a:prstGeom prst="rect">
+            <a:avLst/>
+          </a:prstGeom>
+          <a:noFill/>
+          <a:ln/>
+        </p:spPr>
+        <p:txBody>
+          <a:bodyPr wrap="square" lIns="0" tIns="0" rIns="0" bIns="0" rtlCol="0" anchor="ctr"/>
           <a:lstStyle/>
           <a:p>
             <a:pPr algn="l" indent="0" marL="0">
@@ -37391,39 +37391,59 @@
               <a:buNone/>
             </a:pPr>
             <a:r>
-              <a:rPr lang="en-US" sz="1400" dirty="0">
+              <a:rPr lang="en-US" sz="1100" b="1" dirty="0">
                 <a:solidFill>
                   <a:srgbClr val="1E1208"/>
                 </a:solidFill>
-                <a:latin typeface="Impact" pitchFamily="34" charset="0"/>
-                <a:ea typeface="Impact" pitchFamily="34" charset="-122"/>
-                <a:cs typeface="Impact" pitchFamily="34" charset="-120"/>
-              </a:rPr>
-              <a:t>OF 10</a:t>
-            </a:r>
-            <a:endParaRPr lang="en-US" sz="1400" dirty="0"/>
-          </a:p>
-        </p:txBody>
-      </p:sp>
-      <p:sp>
-        <p:nvSpPr>
-          <p:cNvPr id="28" name="Text 24"/>
-          <p:cNvSpPr/>
-          <p:nvPr/>
-        </p:nvSpPr>
-        <p:spPr>
-          <a:xfrm>
-            <a:off x="8092440" y="4507992"/>
-            <a:ext cx="2743200" cy="594360"/>
-          </a:xfrm>
-          <a:prstGeom prst="rect">
-            <a:avLst/>
-          </a:prstGeom>
-          <a:noFill/>
-          <a:ln/>
-        </p:spPr>
-        <p:txBody>
-          <a:bodyPr wrap="square" lIns="0" tIns="0" rIns="0" bIns="0" rtlCol="0" anchor="t"/>
+                <a:latin typeface="Arial" pitchFamily="34" charset="0"/>
+                <a:ea typeface="Arial" pitchFamily="34" charset="-122"/>
+                <a:cs typeface="Arial" pitchFamily="34" charset="-120"/>
+              </a:rPr>
+              <a:t>want AI-assisted lesson planning</a:t>
+            </a:r>
+            <a:endParaRPr lang="en-US" sz="1100" dirty="0"/>
+          </a:p>
+        </p:txBody>
+      </p:sp>
+      <p:sp>
+        <p:nvSpPr>
+          <p:cNvPr id="26" name="Shape 22"/>
+          <p:cNvSpPr/>
+          <p:nvPr/>
+        </p:nvSpPr>
+        <p:spPr>
+          <a:xfrm>
+            <a:off x="1417320" y="5394960"/>
+            <a:ext cx="9509760" cy="502920"/>
+          </a:xfrm>
+          <a:prstGeom prst="rect">
+            <a:avLst/>
+          </a:prstGeom>
+          <a:solidFill>
+            <a:srgbClr val="1E1208"/>
+          </a:solidFill>
+          <a:ln/>
+        </p:spPr>
+      </p:sp>
+      <p:sp>
+        <p:nvSpPr>
+          <p:cNvPr id="27" name="Text 23"/>
+          <p:cNvSpPr/>
+          <p:nvPr/>
+        </p:nvSpPr>
+        <p:spPr>
+          <a:xfrm>
+            <a:off x="1600200" y="5394960"/>
+            <a:ext cx="9144000" cy="502920"/>
+          </a:xfrm>
+          <a:prstGeom prst="rect">
+            <a:avLst/>
+          </a:prstGeom>
+          <a:noFill/>
+          <a:ln/>
+        </p:spPr>
+        <p:txBody>
+          <a:bodyPr wrap="square" lIns="0" tIns="0" rIns="0" bIns="0" rtlCol="0" anchor="ctr"/>
           <a:lstStyle/>
           <a:p>
             <a:pPr algn="l" indent="0" marL="0">
@@ -37433,76 +37453,14 @@
               <a:buNone/>
             </a:pPr>
             <a:r>
-              <a:rPr lang="en-US" sz="1150" b="1" dirty="0">
-                <a:solidFill>
-                  <a:srgbClr val="1E1208"/>
+              <a:rPr lang="en-US" sz="1300" b="1" dirty="0">
+                <a:solidFill>
+                  <a:srgbClr val="FFFFFF"/>
                 </a:solidFill>
                 <a:latin typeface="Arial" pitchFamily="34" charset="0"/>
                 <a:ea typeface="Arial" pitchFamily="34" charset="-122"/>
                 <a:cs typeface="Arial" pitchFamily="34" charset="-120"/>
               </a:rPr>
-              <a:t>want AI-assisted lesson planning</a:t>
-            </a:r>
-            <a:endParaRPr lang="en-US" sz="1150" dirty="0"/>
-          </a:p>
-        </p:txBody>
-      </p:sp>
-      <p:sp>
-        <p:nvSpPr>
-          <p:cNvPr id="29" name="Shape 25"/>
-          <p:cNvSpPr/>
-          <p:nvPr/>
-        </p:nvSpPr>
-        <p:spPr>
-          <a:xfrm>
-            <a:off x="1417320" y="5394960"/>
-            <a:ext cx="9509760" cy="502920"/>
-          </a:xfrm>
-          <a:prstGeom prst="rect">
-            <a:avLst/>
-          </a:prstGeom>
-          <a:solidFill>
-            <a:srgbClr val="1E1208"/>
-          </a:solidFill>
-          <a:ln/>
-        </p:spPr>
-      </p:sp>
-      <p:sp>
-        <p:nvSpPr>
-          <p:cNvPr id="30" name="Text 26"/>
-          <p:cNvSpPr/>
-          <p:nvPr/>
-        </p:nvSpPr>
-        <p:spPr>
-          <a:xfrm>
-            <a:off x="1600200" y="5394960"/>
-            <a:ext cx="9144000" cy="502920"/>
-          </a:xfrm>
-          <a:prstGeom prst="rect">
-            <a:avLst/>
-          </a:prstGeom>
-          <a:noFill/>
-          <a:ln/>
-        </p:spPr>
-        <p:txBody>
-          <a:bodyPr wrap="square" lIns="0" tIns="0" rIns="0" bIns="0" rtlCol="0" anchor="ctr"/>
-          <a:lstStyle/>
-          <a:p>
-            <a:pPr algn="l" indent="0" marL="0">
-              <a:lnSpc>
-                <a:spcPct val="110000"/>
-              </a:lnSpc>
-              <a:buNone/>
-            </a:pPr>
-            <a:r>
-              <a:rPr lang="en-US" sz="1300" b="1" dirty="0">
-                <a:solidFill>
-                  <a:srgbClr val="FFFFFF"/>
-                </a:solidFill>
-                <a:latin typeface="Arial" pitchFamily="34" charset="0"/>
-                <a:ea typeface="Arial" pitchFamily="34" charset="-122"/>
-                <a:cs typeface="Arial" pitchFamily="34" charset="-120"/>
-              </a:rPr>
               <a:t>"A learning gap tracker that analyses assessment results and suggests activities for reteaching and practice."</a:t>
             </a:r>
             <a:endParaRPr lang="en-US" sz="1300" dirty="0"/>
@@ -37511,7 +37469,7 @@
       </p:sp>
       <p:sp>
         <p:nvSpPr>
-          <p:cNvPr id="31" name="Text 27"/>
+          <p:cNvPr id="28" name="Text 24"/>
           <p:cNvSpPr/>
           <p:nvPr/>
         </p:nvSpPr>
@@ -37943,7 +37901,7 @@
                 <a:ea typeface="Courier New" pitchFamily="34" charset="-122"/>
                 <a:cs typeface="Courier New" pitchFamily="34" charset="-120"/>
               </a:rPr>
-              <a:t>ONE SCHOOL, THREE PRODUCTS</a:t>
+              <a:t>ONE PLATFORM, THREE PRODUCTS</a:t>
             </a:r>
             <a:endParaRPr lang="en-US" sz="1150" dirty="0"/>
           </a:p>

</xml_diff>

<commit_message>
Deck: the two talking-point slides now carry the supplied wording exactly (Smart Assess JA, organizing); extra source footnote removed
Co-Authored-By: Claude Sonnet 5.5 <noreply@anthropic.com>
</commit_message>
<xml_diff>
--- a/marketing/presentation/Smart-Assess-Ja-Manchester-Presentation-v2.pptx
+++ b/marketing/presentation/Smart-Assess-Ja-Manchester-Presentation-v2.pptx
@@ -26710,7 +26710,7 @@
                 <a:ea typeface="Arial" pitchFamily="34" charset="-122"/>
                 <a:cs typeface="Arial" pitchFamily="34" charset="-120"/>
               </a:rPr>
-              <a:t>Smart Assess Ja is designed to connect assessment, learning and practice around the same students, classes and curriculum topics.</a:t>
+              <a:t>Smart Assess JA is designed to connect assessment, learning and practice around the same students, classes and curriculum topics.</a:t>
             </a:r>
             <a:endParaRPr lang="en-US" sz="1800" dirty="0"/>
           </a:p>
@@ -27561,7 +27561,7 @@
                 <a:ea typeface="Arial" pitchFamily="34" charset="-122"/>
                 <a:cs typeface="Arial" pitchFamily="34" charset="-120"/>
               </a:rPr>
-              <a:t>Useful for managing classwork, sharing materials and organising assignments.</a:t>
+              <a:t>Useful for managing classwork, sharing materials and organizing assignments.</a:t>
             </a:r>
             <a:endParaRPr lang="en-US" sz="1700" dirty="0"/>
           </a:p>
@@ -27755,48 +27755,6 @@
               <a:t>The difference is the connected workflow, not just a longer feature list.</a:t>
             </a:r>
             <a:endParaRPr lang="en-US" sz="1600" dirty="0"/>
-          </a:p>
-        </p:txBody>
-      </p:sp>
-      <p:sp>
-        <p:nvSpPr>
-          <p:cNvPr id="24" name="Text 21"/>
-          <p:cNvSpPr/>
-          <p:nvPr/>
-        </p:nvSpPr>
-        <p:spPr>
-          <a:xfrm>
-            <a:off x="1417320" y="6583680"/>
-            <a:ext cx="9509760" cy="274320"/>
-          </a:xfrm>
-          <a:prstGeom prst="rect">
-            <a:avLst/>
-          </a:prstGeom>
-          <a:noFill/>
-          <a:ln/>
-        </p:spPr>
-        <p:txBody>
-          <a:bodyPr wrap="square" lIns="0" tIns="0" rIns="0" bIns="0" rtlCol="0" anchor="t"/>
-          <a:lstStyle/>
-          <a:p>
-            <a:pPr algn="l" indent="0" marL="0">
-              <a:lnSpc>
-                <a:spcPct val="110000"/>
-              </a:lnSpc>
-              <a:buNone/>
-            </a:pPr>
-            <a:r>
-              <a:rPr lang="en-US" sz="900" dirty="0">
-                <a:solidFill>
-                  <a:srgbClr val="555555"/>
-                </a:solidFill>
-                <a:latin typeface="Arial" pitchFamily="34" charset="0"/>
-                <a:ea typeface="Arial" pitchFamily="34" charset="-122"/>
-                <a:cs typeface="Arial" pitchFamily="34" charset="-120"/>
-              </a:rPr>
-              <a:t>Google Classroom: public documentation, October 2026. Every school sets it up differently.</a:t>
-            </a:r>
-            <a:endParaRPr lang="en-US" sz="900" dirty="0"/>
           </a:p>
         </p:txBody>
       </p:sp>

</xml_diff>